<commit_message>
slides(blog): fix [[1]] wikilinks + split S3 for mcp-2026-roadmap-explained [KOEA-1279]
- clean_line: strip [[n]](url) footnote citations entirely before other patterns
- extract_sections: split H2 sections with ≥4 H3 subsections into two slides
- generate: inject "What You'll Learn" slide from learning_objectives when content < 5 sections
- Result: 7 slides (was 5), no raw wikilinks in S3/S6

Co-Authored-By: Claude Sonnet 4.6 <noreply@anthropic.com>
</commit_message>
<xml_diff>
--- a/vault/blogs/mcp-2026-roadmap-explained/slides.pptx
+++ b/vault/blogs/mcp-2026-roadmap-explained/slides.pptx
@@ -10,6 +10,8 @@
     <p:sldId id="258" r:id="rId9"/>
     <p:sldId id="259" r:id="rId10"/>
     <p:sldId id="260" r:id="rId11"/>
+    <p:sldId id="261" r:id="rId12"/>
+    <p:sldId id="262" r:id="rId13"/>
   </p:sldIdLst>
   <p:sldSz cx="12191695" cy="6858000" type="screen4x3"/>
   <p:notesSz cx="6858000" cy="9144000"/>
@@ -3257,7 +3259,7 @@
                   <a:srgbClr val="FFFFFF"/>
                 </a:solidFill>
               </a:rPr>
-              <a:t>Key Facts</a:t>
+              <a:t>What You'll Learn</a:t>
             </a:r>
           </a:p>
         </p:txBody>
@@ -3334,7 +3336,7 @@
                   <a:srgbClr val="FFFFFF"/>
                 </a:solidFill>
               </a:rPr>
-              <a:t>  MCP's 2026 roadmap identifies four priority areas: transport scalability, agent communication (Tasks primitive), enterpr</a:t>
+              <a:t>  Identify the four 2026 MCP priority areas and their concrete builder impact</a:t>
             </a:r>
           </a:p>
         </p:txBody>
@@ -3368,7 +3370,7 @@
                   <a:srgbClr val="FFFFFF"/>
                 </a:solidFill>
               </a:rPr>
-              <a:t>  The spec is migrating from release-based planning to Working Group-driven development, with a formal contributor ladder </a:t>
+              <a:t>  Explain how DPoP (RFC 9449) token binding prevents token theft in MCP auth flows</a:t>
             </a:r>
           </a:p>
         </p:txBody>
@@ -3402,7 +3404,7 @@
                   <a:srgbClr val="FFFFFF"/>
                 </a:solidFill>
               </a:rPr>
-              <a:t>  Two security SEPs are in active review: SEP-1932 (DPoP) and SEP-1933 (Workload Identity Federation) [[1]](https://blog.m</a:t>
+              <a:t>  Understand how the Working Group governance model changes who controls the MCP spec</a:t>
             </a:r>
           </a:p>
         </p:txBody>
@@ -3410,40 +3412,6 @@
       <p:sp>
         <p:nvSpPr>
           <p:cNvPr id="7" name="TextBox 6"/>
-          <p:cNvSpPr txBox="1"/>
-          <p:nvPr/>
-        </p:nvSpPr>
-        <p:spPr>
-          <a:xfrm>
-            <a:off x="731520" y="4754880"/>
-            <a:ext cx="10698480" cy="960120"/>
-          </a:xfrm>
-          <a:prstGeom prst="rect">
-            <a:avLst/>
-          </a:prstGeom>
-          <a:noFill/>
-        </p:spPr>
-        <p:txBody>
-          <a:bodyPr wrap="square">
-            <a:spAutoFit/>
-          </a:bodyPr>
-          <a:lstStyle/>
-          <a:p>
-            <a:pPr algn="l"/>
-            <a:r>
-              <a:rPr sz="1700" b="0">
-                <a:solidFill>
-                  <a:srgbClr val="FFFFFF"/>
-                </a:solidFill>
-              </a:rPr>
-              <a:t>  Transport improvements target stateless HTTP sessions and .well-known server discovery, removing the requirement for a l</a:t>
-            </a:r>
-          </a:p>
-        </p:txBody>
-      </p:sp>
-      <p:sp>
-        <p:nvSpPr>
-          <p:cNvPr id="8" name="TextBox 7"/>
           <p:cNvSpPr txBox="1"/>
           <p:nvPr/>
         </p:nvSpPr>
@@ -3530,7 +3498,7 @@
                   <a:srgbClr val="FFFFFF"/>
                 </a:solidFill>
               </a:rPr>
-              <a:t>The Four Priority Areas — What Changes for You</a:t>
+              <a:t>Key Facts</a:t>
             </a:r>
           </a:p>
         </p:txBody>
@@ -3607,7 +3575,7 @@
                   <a:srgbClr val="FFFFFF"/>
                 </a:solidFill>
               </a:rPr>
-              <a:t>  1. Transport Scalability: Stateless Sessions and Discovery</a:t>
+              <a:t>  MCP's 2026 roadmap identifies four priority areas: transport scalability, agent communication (Tasks primitive), enterpr</a:t>
             </a:r>
           </a:p>
         </p:txBody>
@@ -3641,7 +3609,7 @@
                   <a:srgbClr val="FFFFFF"/>
                 </a:solidFill>
               </a:rPr>
-              <a:t>  The current Streamable HTTP transport requires a stateful session — the connection must stay alive to know what a server</a:t>
+              <a:t>  The spec is migrating from release-based planning to Working Group-driven development, with a formal contributor ladder </a:t>
             </a:r>
           </a:p>
         </p:txBody>
@@ -3675,7 +3643,7 @@
                   <a:srgbClr val="FFFFFF"/>
                 </a:solidFill>
               </a:rPr>
-              <a:t>  Stateless sessions: Horizontal scaling becomes tractable when any server replica can handle any request. Today's statefu</a:t>
+              <a:t>  Two security SEPs are in active review: SEP-1932 (DPoP) and SEP-1933 (Workload Identity Federation)</a:t>
             </a:r>
           </a:p>
         </p:txBody>
@@ -3709,7 +3677,7 @@
                   <a:srgbClr val="FFFFFF"/>
                 </a:solidFill>
               </a:rPr>
-              <a:t>  .well-known metadata: Servers can declare capabilities at a well-known URL without a live connection — the same model th</a:t>
+              <a:t>  Transport improvements target stateless HTTP sessions and .well-known server discovery, removing the requirement for a l</a:t>
             </a:r>
           </a:p>
         </p:txBody>
@@ -3803,7 +3771,7 @@
                   <a:srgbClr val="FFFFFF"/>
                 </a:solidFill>
               </a:rPr>
-              <a:t>The Governance Shift Is the Real Changelog</a:t>
+              <a:t>Transport Scalability &amp; Agent Communication</a:t>
             </a:r>
           </a:p>
         </p:txBody>
@@ -3880,7 +3848,7 @@
                   <a:srgbClr val="FFFFFF"/>
                 </a:solidFill>
               </a:rPr>
-              <a:t>  The most under-reported section of the roadmap is the contributor ladder. Here's the mechanics [[1]](https://blog.modelc</a:t>
+              <a:t>  Transport Scalability</a:t>
             </a:r>
           </a:p>
         </p:txBody>
@@ -3914,7 +3882,7 @@
                   <a:srgbClr val="FFFFFF"/>
                 </a:solidFill>
               </a:rPr>
-              <a:t>  SEPs (Spec Enhancement Proposals) are the formal gate for any protocol change</a:t>
+              <a:t>  The current Streamable HTTP transport requires a stateful session — the connection must stay alive to know what a server</a:t>
             </a:r>
           </a:p>
         </p:txBody>
@@ -3948,7 +3916,7 @@
                   <a:srgbClr val="FFFFFF"/>
                 </a:solidFill>
               </a:rPr>
-              <a:t>  Working Groups are domain-scoped bodies with delegated authority to accept SEPs in their area</a:t>
+              <a:t>  Stateless sessions: Horizontal scaling becomes tractable when any server replica can handle any request. Today's statefu</a:t>
             </a:r>
           </a:p>
         </p:txBody>
@@ -3982,7 +3950,7 @@
                   <a:srgbClr val="FFFFFF"/>
                 </a:solidFill>
               </a:rPr>
-              <a:t>  Core Maintainers retain strategic oversight but no longer need to review every SEP</a:t>
+              <a:t>  Agent Communication</a:t>
             </a:r>
           </a:p>
         </p:txBody>
@@ -4030,6 +3998,552 @@
 </file>
 
 <file path=ppt/slides/slide5.xml><?xml version="1.0" encoding="utf-8"?>
+<p:sld xmlns:a="http://schemas.openxmlformats.org/drawingml/2006/main" xmlns:p="http://schemas.openxmlformats.org/presentationml/2006/main" xmlns:r="http://schemas.openxmlformats.org/officeDocument/2006/relationships">
+  <p:cSld>
+    <p:bg>
+      <p:bgPr>
+        <a:solidFill>
+          <a:srgbClr val="18181B"/>
+        </a:solidFill>
+        <a:effectLst/>
+      </p:bgPr>
+    </p:bg>
+    <p:spTree>
+      <p:nvGrpSpPr>
+        <p:cNvPr id="1" name=""/>
+        <p:cNvGrpSpPr/>
+        <p:nvPr/>
+      </p:nvGrpSpPr>
+      <p:grpSpPr/>
+      <p:sp>
+        <p:nvSpPr>
+          <p:cNvPr id="2" name="TextBox 1"/>
+          <p:cNvSpPr txBox="1"/>
+          <p:nvPr/>
+        </p:nvSpPr>
+        <p:spPr>
+          <a:xfrm>
+            <a:off x="731520" y="411480"/>
+            <a:ext cx="10698480" cy="1005840"/>
+          </a:xfrm>
+          <a:prstGeom prst="rect">
+            <a:avLst/>
+          </a:prstGeom>
+          <a:noFill/>
+        </p:spPr>
+        <p:txBody>
+          <a:bodyPr wrap="square">
+            <a:spAutoFit/>
+          </a:bodyPr>
+          <a:lstStyle/>
+          <a:p>
+            <a:pPr algn="l"/>
+            <a:r>
+              <a:rPr sz="2800" b="1">
+                <a:solidFill>
+                  <a:srgbClr val="FFFFFF"/>
+                </a:solidFill>
+              </a:rPr>
+              <a:t>DPoP and Workload Identity &amp; Enterprise Readiness</a:t>
+            </a:r>
+          </a:p>
+        </p:txBody>
+      </p:sp>
+      <p:sp>
+        <p:nvSpPr>
+          <p:cNvPr id="3" name="Rectangle 2"/>
+          <p:cNvSpPr/>
+          <p:nvPr/>
+        </p:nvSpPr>
+        <p:spPr>
+          <a:xfrm>
+            <a:off x="731520" y="1417320"/>
+            <a:ext cx="10698480" cy="36576"/>
+          </a:xfrm>
+          <a:prstGeom prst="rect">
+            <a:avLst/>
+          </a:prstGeom>
+          <a:solidFill>
+            <a:srgbClr val="A1A1AA"/>
+          </a:solidFill>
+          <a:ln>
+            <a:noFill/>
+          </a:ln>
+        </p:spPr>
+        <p:style>
+          <a:lnRef idx="1">
+            <a:schemeClr val="accent1"/>
+          </a:lnRef>
+          <a:fillRef idx="3">
+            <a:schemeClr val="accent1"/>
+          </a:fillRef>
+          <a:effectRef idx="2">
+            <a:schemeClr val="accent1"/>
+          </a:effectRef>
+          <a:fontRef idx="minor">
+            <a:schemeClr val="lt1"/>
+          </a:fontRef>
+        </p:style>
+        <p:txBody>
+          <a:bodyPr rtlCol="0" anchor="ctr"/>
+          <a:lstStyle/>
+          <a:p>
+            <a:pPr algn="ctr"/>
+          </a:p>
+        </p:txBody>
+      </p:sp>
+      <p:sp>
+        <p:nvSpPr>
+          <p:cNvPr id="4" name="TextBox 3"/>
+          <p:cNvSpPr txBox="1"/>
+          <p:nvPr/>
+        </p:nvSpPr>
+        <p:spPr>
+          <a:xfrm>
+            <a:off x="731520" y="1600200"/>
+            <a:ext cx="10698480" cy="960120"/>
+          </a:xfrm>
+          <a:prstGeom prst="rect">
+            <a:avLst/>
+          </a:prstGeom>
+          <a:noFill/>
+        </p:spPr>
+        <p:txBody>
+          <a:bodyPr wrap="square">
+            <a:spAutoFit/>
+          </a:bodyPr>
+          <a:lstStyle/>
+          <a:p>
+            <a:pPr algn="l"/>
+            <a:r>
+              <a:rPr sz="1700" b="0">
+                <a:solidFill>
+                  <a:srgbClr val="FFFFFF"/>
+                </a:solidFill>
+              </a:rPr>
+              <a:t>  DPoP and Workload Identity</a:t>
+            </a:r>
+          </a:p>
+        </p:txBody>
+      </p:sp>
+      <p:sp>
+        <p:nvSpPr>
+          <p:cNvPr id="5" name="TextBox 4"/>
+          <p:cNvSpPr txBox="1"/>
+          <p:nvPr/>
+        </p:nvSpPr>
+        <p:spPr>
+          <a:xfrm>
+            <a:off x="731520" y="2651760"/>
+            <a:ext cx="10698480" cy="960120"/>
+          </a:xfrm>
+          <a:prstGeom prst="rect">
+            <a:avLst/>
+          </a:prstGeom>
+          <a:noFill/>
+        </p:spPr>
+        <p:txBody>
+          <a:bodyPr wrap="square">
+            <a:spAutoFit/>
+          </a:bodyPr>
+          <a:lstStyle/>
+          <a:p>
+            <a:pPr algn="l"/>
+            <a:r>
+              <a:rPr sz="1700" b="0">
+                <a:solidFill>
+                  <a:srgbClr val="FFFFFF"/>
+                </a:solidFill>
+              </a:rPr>
+              <a:t>  The two in-review SEPs are complementary. SEP-1932 (DPoP, RFC 9449) binds OAuth access tokens to a client's public key a</a:t>
+            </a:r>
+          </a:p>
+        </p:txBody>
+      </p:sp>
+      <p:sp>
+        <p:nvSpPr>
+          <p:cNvPr id="6" name="TextBox 5"/>
+          <p:cNvSpPr txBox="1"/>
+          <p:nvPr/>
+        </p:nvSpPr>
+        <p:spPr>
+          <a:xfrm>
+            <a:off x="731520" y="3703320"/>
+            <a:ext cx="10698480" cy="960120"/>
+          </a:xfrm>
+          <a:prstGeom prst="rect">
+            <a:avLst/>
+          </a:prstGeom>
+          <a:noFill/>
+        </p:spPr>
+        <p:txBody>
+          <a:bodyPr wrap="square">
+            <a:spAutoFit/>
+          </a:bodyPr>
+          <a:lstStyle/>
+          <a:p>
+            <a:pPr algn="l"/>
+            <a:r>
+              <a:rPr sz="1700" b="0">
+                <a:solidFill>
+                  <a:srgbClr val="FFFFFF"/>
+                </a:solidFill>
+              </a:rPr>
+              <a:t>  Together, they move MCP auth from "bearer token passed in a header" to "cryptographically bound credential that proves t</a:t>
+            </a:r>
+          </a:p>
+        </p:txBody>
+      </p:sp>
+      <p:sp>
+        <p:nvSpPr>
+          <p:cNvPr id="7" name="TextBox 6"/>
+          <p:cNvSpPr txBox="1"/>
+          <p:nvPr/>
+        </p:nvSpPr>
+        <p:spPr>
+          <a:xfrm>
+            <a:off x="731520" y="4754880"/>
+            <a:ext cx="10698480" cy="960120"/>
+          </a:xfrm>
+          <a:prstGeom prst="rect">
+            <a:avLst/>
+          </a:prstGeom>
+          <a:noFill/>
+        </p:spPr>
+        <p:txBody>
+          <a:bodyPr wrap="square">
+            <a:spAutoFit/>
+          </a:bodyPr>
+          <a:lstStyle/>
+          <a:p>
+            <a:pPr algn="l"/>
+            <a:r>
+              <a:rPr sz="1700" b="0">
+                <a:solidFill>
+                  <a:srgbClr val="FFFFFF"/>
+                </a:solidFill>
+              </a:rPr>
+              <a:t>  Enterprise Readiness</a:t>
+            </a:r>
+          </a:p>
+        </p:txBody>
+      </p:sp>
+      <p:sp>
+        <p:nvSpPr>
+          <p:cNvPr id="8" name="TextBox 7"/>
+          <p:cNvSpPr txBox="1"/>
+          <p:nvPr/>
+        </p:nvSpPr>
+        <p:spPr>
+          <a:xfrm>
+            <a:off x="731520" y="6263640"/>
+            <a:ext cx="10698480" cy="365760"/>
+          </a:xfrm>
+          <a:prstGeom prst="rect">
+            <a:avLst/>
+          </a:prstGeom>
+          <a:noFill/>
+        </p:spPr>
+        <p:txBody>
+          <a:bodyPr wrap="square">
+            <a:spAutoFit/>
+          </a:bodyPr>
+          <a:lstStyle/>
+          <a:p>
+            <a:pPr algn="l"/>
+            <a:r>
+              <a:rPr sz="1000" b="0">
+                <a:solidFill>
+                  <a:srgbClr val="A1A1AA"/>
+                </a:solidFill>
+              </a:rPr>
+              <a:t>academy.kspl.tech | Koenig AI Academy</a:t>
+            </a:r>
+          </a:p>
+        </p:txBody>
+      </p:sp>
+    </p:spTree>
+  </p:cSld>
+  <p:clrMapOvr>
+    <a:masterClrMapping/>
+  </p:clrMapOvr>
+</p:sld>
+</file>
+
+<file path=ppt/slides/slide6.xml><?xml version="1.0" encoding="utf-8"?>
+<p:sld xmlns:a="http://schemas.openxmlformats.org/drawingml/2006/main" xmlns:p="http://schemas.openxmlformats.org/presentationml/2006/main" xmlns:r="http://schemas.openxmlformats.org/officeDocument/2006/relationships">
+  <p:cSld>
+    <p:bg>
+      <p:bgPr>
+        <a:solidFill>
+          <a:srgbClr val="18181B"/>
+        </a:solidFill>
+        <a:effectLst/>
+      </p:bgPr>
+    </p:bg>
+    <p:spTree>
+      <p:nvGrpSpPr>
+        <p:cNvPr id="1" name=""/>
+        <p:cNvGrpSpPr/>
+        <p:nvPr/>
+      </p:nvGrpSpPr>
+      <p:grpSpPr/>
+      <p:sp>
+        <p:nvSpPr>
+          <p:cNvPr id="2" name="TextBox 1"/>
+          <p:cNvSpPr txBox="1"/>
+          <p:nvPr/>
+        </p:nvSpPr>
+        <p:spPr>
+          <a:xfrm>
+            <a:off x="731520" y="411480"/>
+            <a:ext cx="10698480" cy="1005840"/>
+          </a:xfrm>
+          <a:prstGeom prst="rect">
+            <a:avLst/>
+          </a:prstGeom>
+          <a:noFill/>
+        </p:spPr>
+        <p:txBody>
+          <a:bodyPr wrap="square">
+            <a:spAutoFit/>
+          </a:bodyPr>
+          <a:lstStyle/>
+          <a:p>
+            <a:pPr algn="l"/>
+            <a:r>
+              <a:rPr sz="2800" b="1">
+                <a:solidFill>
+                  <a:srgbClr val="FFFFFF"/>
+                </a:solidFill>
+              </a:rPr>
+              <a:t>The Governance Shift Is the Real Changelog</a:t>
+            </a:r>
+          </a:p>
+        </p:txBody>
+      </p:sp>
+      <p:sp>
+        <p:nvSpPr>
+          <p:cNvPr id="3" name="Rectangle 2"/>
+          <p:cNvSpPr/>
+          <p:nvPr/>
+        </p:nvSpPr>
+        <p:spPr>
+          <a:xfrm>
+            <a:off x="731520" y="1417320"/>
+            <a:ext cx="10698480" cy="36576"/>
+          </a:xfrm>
+          <a:prstGeom prst="rect">
+            <a:avLst/>
+          </a:prstGeom>
+          <a:solidFill>
+            <a:srgbClr val="A1A1AA"/>
+          </a:solidFill>
+          <a:ln>
+            <a:noFill/>
+          </a:ln>
+        </p:spPr>
+        <p:style>
+          <a:lnRef idx="1">
+            <a:schemeClr val="accent1"/>
+          </a:lnRef>
+          <a:fillRef idx="3">
+            <a:schemeClr val="accent1"/>
+          </a:fillRef>
+          <a:effectRef idx="2">
+            <a:schemeClr val="accent1"/>
+          </a:effectRef>
+          <a:fontRef idx="minor">
+            <a:schemeClr val="lt1"/>
+          </a:fontRef>
+        </p:style>
+        <p:txBody>
+          <a:bodyPr rtlCol="0" anchor="ctr"/>
+          <a:lstStyle/>
+          <a:p>
+            <a:pPr algn="ctr"/>
+          </a:p>
+        </p:txBody>
+      </p:sp>
+      <p:sp>
+        <p:nvSpPr>
+          <p:cNvPr id="4" name="TextBox 3"/>
+          <p:cNvSpPr txBox="1"/>
+          <p:nvPr/>
+        </p:nvSpPr>
+        <p:spPr>
+          <a:xfrm>
+            <a:off x="731520" y="1600200"/>
+            <a:ext cx="10698480" cy="960120"/>
+          </a:xfrm>
+          <a:prstGeom prst="rect">
+            <a:avLst/>
+          </a:prstGeom>
+          <a:noFill/>
+        </p:spPr>
+        <p:txBody>
+          <a:bodyPr wrap="square">
+            <a:spAutoFit/>
+          </a:bodyPr>
+          <a:lstStyle/>
+          <a:p>
+            <a:pPr algn="l"/>
+            <a:r>
+              <a:rPr sz="1700" b="0">
+                <a:solidFill>
+                  <a:srgbClr val="FFFFFF"/>
+                </a:solidFill>
+              </a:rPr>
+              <a:t>  The most under-reported section of the roadmap is the contributor ladder. Here's the mechanics :</a:t>
+            </a:r>
+          </a:p>
+        </p:txBody>
+      </p:sp>
+      <p:sp>
+        <p:nvSpPr>
+          <p:cNvPr id="5" name="TextBox 4"/>
+          <p:cNvSpPr txBox="1"/>
+          <p:nvPr/>
+        </p:nvSpPr>
+        <p:spPr>
+          <a:xfrm>
+            <a:off x="731520" y="2651760"/>
+            <a:ext cx="10698480" cy="960120"/>
+          </a:xfrm>
+          <a:prstGeom prst="rect">
+            <a:avLst/>
+          </a:prstGeom>
+          <a:noFill/>
+        </p:spPr>
+        <p:txBody>
+          <a:bodyPr wrap="square">
+            <a:spAutoFit/>
+          </a:bodyPr>
+          <a:lstStyle/>
+          <a:p>
+            <a:pPr algn="l"/>
+            <a:r>
+              <a:rPr sz="1700" b="0">
+                <a:solidFill>
+                  <a:srgbClr val="FFFFFF"/>
+                </a:solidFill>
+              </a:rPr>
+              <a:t>  SEPs (Spec Enhancement Proposals) are the formal gate for any protocol change</a:t>
+            </a:r>
+          </a:p>
+        </p:txBody>
+      </p:sp>
+      <p:sp>
+        <p:nvSpPr>
+          <p:cNvPr id="6" name="TextBox 5"/>
+          <p:cNvSpPr txBox="1"/>
+          <p:nvPr/>
+        </p:nvSpPr>
+        <p:spPr>
+          <a:xfrm>
+            <a:off x="731520" y="3703320"/>
+            <a:ext cx="10698480" cy="960120"/>
+          </a:xfrm>
+          <a:prstGeom prst="rect">
+            <a:avLst/>
+          </a:prstGeom>
+          <a:noFill/>
+        </p:spPr>
+        <p:txBody>
+          <a:bodyPr wrap="square">
+            <a:spAutoFit/>
+          </a:bodyPr>
+          <a:lstStyle/>
+          <a:p>
+            <a:pPr algn="l"/>
+            <a:r>
+              <a:rPr sz="1700" b="0">
+                <a:solidFill>
+                  <a:srgbClr val="FFFFFF"/>
+                </a:solidFill>
+              </a:rPr>
+              <a:t>  Working Groups are domain-scoped bodies with delegated authority to accept SEPs in their area</a:t>
+            </a:r>
+          </a:p>
+        </p:txBody>
+      </p:sp>
+      <p:sp>
+        <p:nvSpPr>
+          <p:cNvPr id="7" name="TextBox 6"/>
+          <p:cNvSpPr txBox="1"/>
+          <p:nvPr/>
+        </p:nvSpPr>
+        <p:spPr>
+          <a:xfrm>
+            <a:off x="731520" y="4754880"/>
+            <a:ext cx="10698480" cy="960120"/>
+          </a:xfrm>
+          <a:prstGeom prst="rect">
+            <a:avLst/>
+          </a:prstGeom>
+          <a:noFill/>
+        </p:spPr>
+        <p:txBody>
+          <a:bodyPr wrap="square">
+            <a:spAutoFit/>
+          </a:bodyPr>
+          <a:lstStyle/>
+          <a:p>
+            <a:pPr algn="l"/>
+            <a:r>
+              <a:rPr sz="1700" b="0">
+                <a:solidFill>
+                  <a:srgbClr val="FFFFFF"/>
+                </a:solidFill>
+              </a:rPr>
+              <a:t>  Core Maintainers retain strategic oversight but no longer need to review every SEP</a:t>
+            </a:r>
+          </a:p>
+        </p:txBody>
+      </p:sp>
+      <p:sp>
+        <p:nvSpPr>
+          <p:cNvPr id="8" name="TextBox 7"/>
+          <p:cNvSpPr txBox="1"/>
+          <p:nvPr/>
+        </p:nvSpPr>
+        <p:spPr>
+          <a:xfrm>
+            <a:off x="731520" y="6263640"/>
+            <a:ext cx="10698480" cy="365760"/>
+          </a:xfrm>
+          <a:prstGeom prst="rect">
+            <a:avLst/>
+          </a:prstGeom>
+          <a:noFill/>
+        </p:spPr>
+        <p:txBody>
+          <a:bodyPr wrap="square">
+            <a:spAutoFit/>
+          </a:bodyPr>
+          <a:lstStyle/>
+          <a:p>
+            <a:pPr algn="l"/>
+            <a:r>
+              <a:rPr sz="1000" b="0">
+                <a:solidFill>
+                  <a:srgbClr val="A1A1AA"/>
+                </a:solidFill>
+              </a:rPr>
+              <a:t>academy.kspl.tech | Koenig AI Academy</a:t>
+            </a:r>
+          </a:p>
+        </p:txBody>
+      </p:sp>
+    </p:spTree>
+  </p:cSld>
+  <p:clrMapOvr>
+    <a:masterClrMapping/>
+  </p:clrMapOvr>
+</p:sld>
+</file>
+
+<file path=ppt/slides/slide7.xml><?xml version="1.0" encoding="utf-8"?>
 <p:sld xmlns:a="http://schemas.openxmlformats.org/drawingml/2006/main" xmlns:p="http://schemas.openxmlformats.org/presentationml/2006/main" xmlns:r="http://schemas.openxmlformats.org/officeDocument/2006/relationships">
   <p:cSld>
     <p:bg>

</xml_diff>